<commit_message>
Add flow-diagram slides: per-feature How It Works, module comparisons, opening shape slide
- build.py renders Flow: A -> B -> C outline lines as box-and-arrow rows (optional row labels); body text sizes to the remaining room
- 16 new slides: The Shape of Every Feature (opening), comparison diagrams opening each module, a How It Works flow per feature 01-10, RAG-vs-agent contrast in M4
- Runsheets and slides.md updated for new slide numbers; decks rebuilt

Co-Authored-By: Claude Fable 5 <noreply@anthropic.com>
Claude-Session: https://claude.ai/code/session_01VRYE7jQ9H6VBeAEztwqeiM
</commit_message>
<xml_diff>
--- a/docs/slides/pptx/00-opening.pptx
+++ b/docs/slides/pptx/00-opening.pptx
@@ -20,6 +20,7 @@
     <p:sldId id="268" r:id="rId20"/>
     <p:sldId id="269" r:id="rId21"/>
     <p:sldId id="270" r:id="rId22"/>
+    <p:sldId id="271" r:id="rId23"/>
   </p:sldIdLst>
   <p:sldSz cx="12191695" cy="6858000" type="screen4x3"/>
   <p:notesSz cx="6858000" cy="9144000"/>
@@ -726,7 +727,7 @@
           <a:lstStyle/>
           <a:p>
             <a:r>
-              <a:t>Show one request to each on screen: the smoke test's local chat and its cloud chat, side by side. Point at the URL and the header. This is why "any language" is true and why local-to-cloud is a config change, which the next slide makes concrete in code.</a:t>
+              <a:t>Put this up before the HTTP slide and leave the picture in people's heads for the day. Every module opens with a version of this diagram with more boxes; point back to this one each time.</a:t>
             </a:r>
           </a:p>
         </p:txBody>
@@ -796,7 +797,7 @@
           <a:lstStyle/>
           <a:p>
             <a:r>
-              <a:t>This is the one "framework" slide of the day. Show the two registration lines side by side, and then move on; that is all the framework talk the day needs.</a:t>
+              <a:t>Show one request to each on screen: the smoke test's local chat and its cloud chat, side by side. Point at the URL and the header. This is why "any language" is true and why local-to-cloud is a config change, which the next slide makes concrete in code.</a:t>
             </a:r>
           </a:p>
         </p:txBody>
@@ -866,7 +867,7 @@
           <a:lstStyle/>
           <a:p>
             <a:r>
-              <a:t>Two minutes, not a tour; each lab doc describes its own data when people get there. Open one trip report on screen and scroll it slowly; that is the problem feature 01 is about to solve. Mention two planted facts people will meet repeatedly: the washed-out footbridge on Avalanche Lake Trail (trail-0117), and a bear-activity spike two trails over.</a:t>
+              <a:t>This is the one "framework" slide of the day. Show the two registration lines side by side, and then move on; that is all the framework talk the day needs.</a:t>
             </a:r>
           </a:p>
         </p:txBody>
@@ -892,6 +893,76 @@
 </file>
 
 <file path=ppt/notesSlides/notesSlide15.xml><?xml version="1.0" encoding="utf-8"?>
+<p:notes xmlns:a="http://schemas.openxmlformats.org/drawingml/2006/main" xmlns:p="http://schemas.openxmlformats.org/presentationml/2006/main" xmlns:r="http://schemas.openxmlformats.org/officeDocument/2006/relationships">
+  <p:cSld>
+    <p:spTree>
+      <p:nvGrpSpPr>
+        <p:cNvPr id="1" name=""/>
+        <p:cNvGrpSpPr/>
+        <p:nvPr/>
+      </p:nvGrpSpPr>
+      <p:grpSpPr>
+        <a:xfrm>
+          <a:off x="0" y="0"/>
+          <a:ext cx="0" cy="0"/>
+          <a:chOff x="0" y="0"/>
+          <a:chExt cx="0" cy="0"/>
+        </a:xfrm>
+      </p:grpSpPr>
+      <p:sp>
+        <p:nvSpPr>
+          <p:cNvPr id="2" name="Slide Image Placeholder 1"/>
+          <p:cNvSpPr>
+            <a:spLocks noGrp="1"/>
+          </p:cNvSpPr>
+          <p:nvPr>
+            <p:ph type="sldImg" idx="2"/>
+          </p:nvPr>
+        </p:nvSpPr>
+        <p:spPr/>
+      </p:sp>
+      <p:sp>
+        <p:nvSpPr>
+          <p:cNvPr id="3" name="Notes Placeholder 2"/>
+          <p:cNvSpPr>
+            <a:spLocks noGrp="1"/>
+          </p:cNvSpPr>
+          <p:nvPr>
+            <p:ph type="body" idx="3" sz="quarter"/>
+          </p:nvPr>
+        </p:nvSpPr>
+        <p:spPr/>
+        <p:txBody>
+          <a:bodyPr/>
+          <a:lstStyle/>
+          <a:p>
+            <a:r>
+              <a:t>Two minutes, not a tour; each lab doc describes its own data when people get there. Open one trip report on screen and scroll it slowly; that is the problem feature 01 is about to solve. Mention two planted facts people will meet repeatedly: the washed-out footbridge on Avalanche Lake Trail (trail-0117), and a bear-activity spike two trails over.</a:t>
+            </a:r>
+          </a:p>
+        </p:txBody>
+      </p:sp>
+      <p:sp>
+        <p:nvSpPr>
+          <p:cNvPr id="4" name="Slide Number Placeholder 3"/>
+          <p:cNvSpPr>
+            <a:spLocks noGrp="1"/>
+          </p:cNvSpPr>
+          <p:nvPr>
+            <p:ph type="sldNum" idx="5" sz="quarter"/>
+          </p:nvPr>
+        </p:nvSpPr>
+        <p:spPr/>
+      </p:sp>
+    </p:spTree>
+  </p:cSld>
+  <p:clrMapOvr>
+    <a:masterClrMapping/>
+  </p:clrMapOvr>
+</p:notes>
+</file>
+
+<file path=ppt/notesSlides/notesSlide16.xml><?xml version="1.0" encoding="utf-8"?>
 <p:notes xmlns:a="http://schemas.openxmlformats.org/drawingml/2006/main" xmlns:p="http://schemas.openxmlformats.org/presentationml/2006/main" xmlns:r="http://schemas.openxmlformats.org/officeDocument/2006/relationships">
   <p:cSld>
     <p:spTree>
@@ -4621,7 +4692,7 @@
         <p:spPr>
           <a:xfrm>
             <a:off x="612648" y="1600200"/>
-            <a:ext cx="10966399" cy="4800600"/>
+            <a:ext cx="10966399" cy="4892040"/>
           </a:xfrm>
         </p:spPr>
         <p:txBody>
@@ -4714,7 +4785,7 @@
         <p:spPr>
           <a:xfrm>
             <a:off x="612648" y="1600200"/>
-            <a:ext cx="10966399" cy="4800600"/>
+            <a:ext cx="10966399" cy="4892040"/>
           </a:xfrm>
         </p:spPr>
         <p:txBody>
@@ -4782,7 +4853,7 @@
           <a:lstStyle/>
           <a:p>
             <a:r>
-              <a:t>Every Model Is an HTTP Call</a:t>
+              <a:t>The Shape of Every Feature</a:t>
             </a:r>
           </a:p>
         </p:txBody>
@@ -4799,8 +4870,8 @@
         </p:nvSpPr>
         <p:spPr>
           <a:xfrm>
-            <a:off x="612648" y="1600200"/>
-            <a:ext cx="10966399" cy="4800600"/>
+            <a:off x="612648" y="3099816"/>
+            <a:ext cx="10966399" cy="3392424"/>
           </a:xfrm>
         </p:spPr>
         <p:txBody>
@@ -4809,29 +4880,458 @@
           <a:p>
             <a:pPr/>
             <a:r>
-              <a:rPr sz="2000"/>
-              <a:t>Ollama is a local server on localhost:11434: native /api/chat and /api/embed, plus an OpenAI-compatible /v1</a:t>
+              <a:rPr sz="1600"/>
+              <a:t>Ten features, one shape. What changes is the data going in, the instruction, and what your code does with what comes back</a:t>
             </a:r>
           </a:p>
           <a:p>
             <a:pPr/>
             <a:r>
-              <a:rPr sz="2000"/>
-              <a:t>Foundry serves gpt-4.1 and gpt-5.5 at …openai.azure.com/openai/deployments/&lt;name&gt;/chat/completions with an api-key header</a:t>
+              <a:rPr sz="1600"/>
+              <a:t>The model is one box in the middle. Everything around it is ordinary software you already know how to write</a:t>
             </a:r>
           </a:p>
           <a:p>
             <a:pPr/>
             <a:r>
-              <a:rPr sz="2000"/>
-              <a:t>Same request shape both places, so the SDKs differ by a constructor and the .http files differ by a URL and a key</a:t>
-            </a:r>
-          </a:p>
-          <a:p>
-            <a:pPr/>
-            <a:r>
-              <a:rPr sz="2000"/>
-              <a:t>The http/ track is the real thing with the SDK removed; Microsoft.Extensions.AI and the openai package are wrappers over these POSTs</a:t>
+              <a:rPr sz="1600"/>
+              <a:t>Modules 2 to 4 add boxes to this line (a vector store, a retrieval step, a tool loop) and never replace it</a:t>
+            </a:r>
+          </a:p>
+        </p:txBody>
+      </p:sp>
+      <p:sp>
+        <p:nvSpPr>
+          <p:cNvPr id="4" name="Rounded Rectangle 3"/>
+          <p:cNvSpPr/>
+          <p:nvPr/>
+        </p:nvSpPr>
+        <p:spPr>
+          <a:xfrm>
+            <a:off x="612648" y="1554480"/>
+            <a:ext cx="1864095" cy="1271016"/>
+          </a:xfrm>
+          <a:prstGeom prst="roundRect">
+            <a:avLst/>
+          </a:prstGeom>
+          <a:noFill/>
+          <a:ln w="19050">
+            <a:solidFill>
+              <a:srgbClr val="000000"/>
+            </a:solidFill>
+          </a:ln>
+          <a:effectLst/>
+        </p:spPr>
+        <p:style>
+          <a:lnRef idx="1">
+            <a:schemeClr val="accent1"/>
+          </a:lnRef>
+          <a:fillRef idx="3">
+            <a:schemeClr val="accent1"/>
+          </a:fillRef>
+          <a:effectRef idx="2">
+            <a:schemeClr val="accent1"/>
+          </a:effectRef>
+          <a:fontRef idx="minor">
+            <a:schemeClr val="lt1"/>
+          </a:fontRef>
+        </p:style>
+        <p:txBody>
+          <a:bodyPr rtlCol="0" anchor="ctr" wrap="square" lIns="73152" rIns="73152"/>
+          <a:lstStyle/>
+          <a:p>
+            <a:pPr algn="ctr"/>
+            <a:r>
+              <a:rPr sz="1300">
+                <a:solidFill>
+                  <a:srgbClr val="000000"/>
+                </a:solidFill>
+              </a:rPr>
+              <a:t>Your data (a report, a query, an inbox)</a:t>
+            </a:r>
+          </a:p>
+        </p:txBody>
+      </p:sp>
+      <p:sp>
+        <p:nvSpPr>
+          <p:cNvPr id="5" name="Right Arrow 4"/>
+          <p:cNvSpPr/>
+          <p:nvPr/>
+        </p:nvSpPr>
+        <p:spPr>
+          <a:xfrm>
+            <a:off x="2531607" y="2043684"/>
+            <a:ext cx="301752" cy="292608"/>
+          </a:xfrm>
+          <a:prstGeom prst="rightArrow">
+            <a:avLst/>
+          </a:prstGeom>
+          <a:solidFill>
+            <a:srgbClr val="000000"/>
+          </a:solidFill>
+          <a:ln>
+            <a:noFill/>
+          </a:ln>
+          <a:effectLst/>
+        </p:spPr>
+        <p:style>
+          <a:lnRef idx="1">
+            <a:schemeClr val="accent1"/>
+          </a:lnRef>
+          <a:fillRef idx="3">
+            <a:schemeClr val="accent1"/>
+          </a:fillRef>
+          <a:effectRef idx="2">
+            <a:schemeClr val="accent1"/>
+          </a:effectRef>
+          <a:fontRef idx="minor">
+            <a:schemeClr val="lt1"/>
+          </a:fontRef>
+        </p:style>
+        <p:txBody>
+          <a:bodyPr rtlCol="0" anchor="ctr"/>
+          <a:lstStyle/>
+          <a:p>
+            <a:pPr algn="ctr"/>
+          </a:p>
+        </p:txBody>
+      </p:sp>
+      <p:sp>
+        <p:nvSpPr>
+          <p:cNvPr id="6" name="Rounded Rectangle 5"/>
+          <p:cNvSpPr/>
+          <p:nvPr/>
+        </p:nvSpPr>
+        <p:spPr>
+          <a:xfrm>
+            <a:off x="2888223" y="1554480"/>
+            <a:ext cx="1864095" cy="1271016"/>
+          </a:xfrm>
+          <a:prstGeom prst="roundRect">
+            <a:avLst/>
+          </a:prstGeom>
+          <a:noFill/>
+          <a:ln w="19050">
+            <a:solidFill>
+              <a:srgbClr val="000000"/>
+            </a:solidFill>
+          </a:ln>
+          <a:effectLst/>
+        </p:spPr>
+        <p:style>
+          <a:lnRef idx="1">
+            <a:schemeClr val="accent1"/>
+          </a:lnRef>
+          <a:fillRef idx="3">
+            <a:schemeClr val="accent1"/>
+          </a:fillRef>
+          <a:effectRef idx="2">
+            <a:schemeClr val="accent1"/>
+          </a:effectRef>
+          <a:fontRef idx="minor">
+            <a:schemeClr val="lt1"/>
+          </a:fontRef>
+        </p:style>
+        <p:txBody>
+          <a:bodyPr rtlCol="0" anchor="ctr" wrap="square" lIns="73152" rIns="73152"/>
+          <a:lstStyle/>
+          <a:p>
+            <a:pPr algn="ctr"/>
+            <a:r>
+              <a:rPr sz="1300">
+                <a:solidFill>
+                  <a:srgbClr val="000000"/>
+                </a:solidFill>
+              </a:rPr>
+              <a:t>Prompt: instruction + data + the shape you want back</a:t>
+            </a:r>
+          </a:p>
+        </p:txBody>
+      </p:sp>
+      <p:sp>
+        <p:nvSpPr>
+          <p:cNvPr id="7" name="Right Arrow 6"/>
+          <p:cNvSpPr/>
+          <p:nvPr/>
+        </p:nvSpPr>
+        <p:spPr>
+          <a:xfrm>
+            <a:off x="4807183" y="2043684"/>
+            <a:ext cx="301752" cy="292608"/>
+          </a:xfrm>
+          <a:prstGeom prst="rightArrow">
+            <a:avLst/>
+          </a:prstGeom>
+          <a:solidFill>
+            <a:srgbClr val="000000"/>
+          </a:solidFill>
+          <a:ln>
+            <a:noFill/>
+          </a:ln>
+          <a:effectLst/>
+        </p:spPr>
+        <p:style>
+          <a:lnRef idx="1">
+            <a:schemeClr val="accent1"/>
+          </a:lnRef>
+          <a:fillRef idx="3">
+            <a:schemeClr val="accent1"/>
+          </a:fillRef>
+          <a:effectRef idx="2">
+            <a:schemeClr val="accent1"/>
+          </a:effectRef>
+          <a:fontRef idx="minor">
+            <a:schemeClr val="lt1"/>
+          </a:fontRef>
+        </p:style>
+        <p:txBody>
+          <a:bodyPr rtlCol="0" anchor="ctr"/>
+          <a:lstStyle/>
+          <a:p>
+            <a:pPr algn="ctr"/>
+          </a:p>
+        </p:txBody>
+      </p:sp>
+      <p:sp>
+        <p:nvSpPr>
+          <p:cNvPr id="8" name="Rounded Rectangle 7"/>
+          <p:cNvSpPr/>
+          <p:nvPr/>
+        </p:nvSpPr>
+        <p:spPr>
+          <a:xfrm>
+            <a:off x="5163799" y="1554480"/>
+            <a:ext cx="1864095" cy="1271016"/>
+          </a:xfrm>
+          <a:prstGeom prst="roundRect">
+            <a:avLst/>
+          </a:prstGeom>
+          <a:noFill/>
+          <a:ln w="19050">
+            <a:solidFill>
+              <a:srgbClr val="000000"/>
+            </a:solidFill>
+          </a:ln>
+          <a:effectLst/>
+        </p:spPr>
+        <p:style>
+          <a:lnRef idx="1">
+            <a:schemeClr val="accent1"/>
+          </a:lnRef>
+          <a:fillRef idx="3">
+            <a:schemeClr val="accent1"/>
+          </a:fillRef>
+          <a:effectRef idx="2">
+            <a:schemeClr val="accent1"/>
+          </a:effectRef>
+          <a:fontRef idx="minor">
+            <a:schemeClr val="lt1"/>
+          </a:fontRef>
+        </p:style>
+        <p:txBody>
+          <a:bodyPr rtlCol="0" anchor="ctr" wrap="square" lIns="73152" rIns="73152"/>
+          <a:lstStyle/>
+          <a:p>
+            <a:pPr algn="ctr"/>
+            <a:r>
+              <a:rPr sz="1300">
+                <a:solidFill>
+                  <a:srgbClr val="000000"/>
+                </a:solidFill>
+              </a:rPr>
+              <a:t>Model, over HTTP (Ollama or Foundry)</a:t>
+            </a:r>
+          </a:p>
+        </p:txBody>
+      </p:sp>
+      <p:sp>
+        <p:nvSpPr>
+          <p:cNvPr id="9" name="Right Arrow 8"/>
+          <p:cNvSpPr/>
+          <p:nvPr/>
+        </p:nvSpPr>
+        <p:spPr>
+          <a:xfrm>
+            <a:off x="7082759" y="2043684"/>
+            <a:ext cx="301752" cy="292608"/>
+          </a:xfrm>
+          <a:prstGeom prst="rightArrow">
+            <a:avLst/>
+          </a:prstGeom>
+          <a:solidFill>
+            <a:srgbClr val="000000"/>
+          </a:solidFill>
+          <a:ln>
+            <a:noFill/>
+          </a:ln>
+          <a:effectLst/>
+        </p:spPr>
+        <p:style>
+          <a:lnRef idx="1">
+            <a:schemeClr val="accent1"/>
+          </a:lnRef>
+          <a:fillRef idx="3">
+            <a:schemeClr val="accent1"/>
+          </a:fillRef>
+          <a:effectRef idx="2">
+            <a:schemeClr val="accent1"/>
+          </a:effectRef>
+          <a:fontRef idx="minor">
+            <a:schemeClr val="lt1"/>
+          </a:fontRef>
+        </p:style>
+        <p:txBody>
+          <a:bodyPr rtlCol="0" anchor="ctr"/>
+          <a:lstStyle/>
+          <a:p>
+            <a:pPr algn="ctr"/>
+          </a:p>
+        </p:txBody>
+      </p:sp>
+      <p:sp>
+        <p:nvSpPr>
+          <p:cNvPr id="10" name="Rounded Rectangle 9"/>
+          <p:cNvSpPr/>
+          <p:nvPr/>
+        </p:nvSpPr>
+        <p:spPr>
+          <a:xfrm>
+            <a:off x="7439375" y="1554480"/>
+            <a:ext cx="1864095" cy="1271016"/>
+          </a:xfrm>
+          <a:prstGeom prst="roundRect">
+            <a:avLst/>
+          </a:prstGeom>
+          <a:noFill/>
+          <a:ln w="19050">
+            <a:solidFill>
+              <a:srgbClr val="000000"/>
+            </a:solidFill>
+          </a:ln>
+          <a:effectLst/>
+        </p:spPr>
+        <p:style>
+          <a:lnRef idx="1">
+            <a:schemeClr val="accent1"/>
+          </a:lnRef>
+          <a:fillRef idx="3">
+            <a:schemeClr val="accent1"/>
+          </a:fillRef>
+          <a:effectRef idx="2">
+            <a:schemeClr val="accent1"/>
+          </a:effectRef>
+          <a:fontRef idx="minor">
+            <a:schemeClr val="lt1"/>
+          </a:fontRef>
+        </p:style>
+        <p:txBody>
+          <a:bodyPr rtlCol="0" anchor="ctr" wrap="square" lIns="73152" rIns="73152"/>
+          <a:lstStyle/>
+          <a:p>
+            <a:pPr algn="ctr"/>
+            <a:r>
+              <a:rPr sz="1300">
+                <a:solidFill>
+                  <a:srgbClr val="000000"/>
+                </a:solidFill>
+              </a:rPr>
+              <a:t>Output your code checks</a:t>
+            </a:r>
+          </a:p>
+        </p:txBody>
+      </p:sp>
+      <p:sp>
+        <p:nvSpPr>
+          <p:cNvPr id="11" name="Right Arrow 10"/>
+          <p:cNvSpPr/>
+          <p:nvPr/>
+        </p:nvSpPr>
+        <p:spPr>
+          <a:xfrm>
+            <a:off x="9358335" y="2043684"/>
+            <a:ext cx="301752" cy="292608"/>
+          </a:xfrm>
+          <a:prstGeom prst="rightArrow">
+            <a:avLst/>
+          </a:prstGeom>
+          <a:solidFill>
+            <a:srgbClr val="000000"/>
+          </a:solidFill>
+          <a:ln>
+            <a:noFill/>
+          </a:ln>
+          <a:effectLst/>
+        </p:spPr>
+        <p:style>
+          <a:lnRef idx="1">
+            <a:schemeClr val="accent1"/>
+          </a:lnRef>
+          <a:fillRef idx="3">
+            <a:schemeClr val="accent1"/>
+          </a:fillRef>
+          <a:effectRef idx="2">
+            <a:schemeClr val="accent1"/>
+          </a:effectRef>
+          <a:fontRef idx="minor">
+            <a:schemeClr val="lt1"/>
+          </a:fontRef>
+        </p:style>
+        <p:txBody>
+          <a:bodyPr rtlCol="0" anchor="ctr"/>
+          <a:lstStyle/>
+          <a:p>
+            <a:pPr algn="ctr"/>
+          </a:p>
+        </p:txBody>
+      </p:sp>
+      <p:sp>
+        <p:nvSpPr>
+          <p:cNvPr id="12" name="Rounded Rectangle 11"/>
+          <p:cNvSpPr/>
+          <p:nvPr/>
+        </p:nvSpPr>
+        <p:spPr>
+          <a:xfrm>
+            <a:off x="9714951" y="1554480"/>
+            <a:ext cx="1864095" cy="1271016"/>
+          </a:xfrm>
+          <a:prstGeom prst="roundRect">
+            <a:avLst/>
+          </a:prstGeom>
+          <a:noFill/>
+          <a:ln w="19050">
+            <a:solidFill>
+              <a:srgbClr val="000000"/>
+            </a:solidFill>
+          </a:ln>
+          <a:effectLst/>
+        </p:spPr>
+        <p:style>
+          <a:lnRef idx="1">
+            <a:schemeClr val="accent1"/>
+          </a:lnRef>
+          <a:fillRef idx="3">
+            <a:schemeClr val="accent1"/>
+          </a:fillRef>
+          <a:effectRef idx="2">
+            <a:schemeClr val="accent1"/>
+          </a:effectRef>
+          <a:fontRef idx="minor">
+            <a:schemeClr val="lt1"/>
+          </a:fontRef>
+        </p:style>
+        <p:txBody>
+          <a:bodyPr rtlCol="0" anchor="ctr" wrap="square" lIns="73152" rIns="73152"/>
+          <a:lstStyle/>
+          <a:p>
+            <a:pPr algn="ctr"/>
+            <a:r>
+              <a:rPr sz="1300">
+                <a:solidFill>
+                  <a:srgbClr val="000000"/>
+                </a:solidFill>
+              </a:rPr>
+              <a:t>Your UI</a:t>
             </a:r>
           </a:p>
         </p:txBody>
@@ -4875,7 +5375,7 @@
           <a:lstStyle/>
           <a:p>
             <a:r>
-              <a:t>One Line of Code, Any Provider</a:t>
+              <a:t>Every Model Is an HTTP Call</a:t>
             </a:r>
           </a:p>
         </p:txBody>
@@ -4893,7 +5393,7 @@
         <p:spPr>
           <a:xfrm>
             <a:off x="612648" y="1600200"/>
-            <a:ext cx="10966399" cy="4800600"/>
+            <a:ext cx="10966399" cy="4892040"/>
           </a:xfrm>
         </p:spPr>
         <p:txBody>
@@ -4903,21 +5403,28 @@
             <a:pPr/>
             <a:r>
               <a:rPr sz="2000"/>
-              <a:t>Every .NET demo uses Microsoft.Extensions.AI: IChatClient, IEmbeddingGenerator</a:t>
+              <a:t>Ollama is a local server on localhost:11434: native /api/chat and /api/embed, plus an OpenAI-compatible /v1</a:t>
             </a:r>
           </a:p>
           <a:p>
             <a:pPr/>
             <a:r>
               <a:rPr sz="2000"/>
-              <a:t>Ollama today, Azure OpenAI tomorrow, is a change in DI registration, not in the feature</a:t>
+              <a:t>Foundry serves gpt-4.1 and gpt-5.5 at …openai.azure.com/openai/deployments/&lt;name&gt;/chat/completions with an api-key header</a:t>
             </a:r>
           </a:p>
           <a:p>
             <a:pPr/>
             <a:r>
               <a:rPr sz="2000"/>
-              <a:t>Feature 03 does the swap live; feature 05 does it again for generation</a:t>
+              <a:t>Same request shape both places, so the SDKs differ by a constructor and the .http files differ by a URL and a key</a:t>
+            </a:r>
+          </a:p>
+          <a:p>
+            <a:pPr/>
+            <a:r>
+              <a:rPr sz="2000"/>
+              <a:t>The http/ track is the real thing with the SDK removed; Microsoft.Extensions.AI and the openai package are wrappers over these POSTs</a:t>
             </a:r>
           </a:p>
         </p:txBody>
@@ -4961,7 +5468,7 @@
           <a:lstStyle/>
           <a:p>
             <a:r>
-              <a:t>Meet Trailhead Guides</a:t>
+              <a:t>One Line of Code, Any Provider</a:t>
             </a:r>
           </a:p>
         </p:txBody>
@@ -4979,7 +5486,7 @@
         <p:spPr>
           <a:xfrm>
             <a:off x="612648" y="1600200"/>
-            <a:ext cx="10966399" cy="4800600"/>
+            <a:ext cx="10966399" cy="4892040"/>
           </a:xfrm>
         </p:spPr>
         <p:txBody>
@@ -4989,21 +5496,21 @@
             <a:pPr/>
             <a:r>
               <a:rPr sz="2000"/>
-              <a:t>A fictional national-park trip-planning app, one deliberately messy corpus, reused all day; each feature's data/ holds what its lab reads</a:t>
+              <a:t>Every .NET demo uses Microsoft.Extensions.AI: IChatClient, IEmbeddingGenerator</a:t>
             </a:r>
           </a:p>
           <a:p>
             <a:pPr/>
             <a:r>
               <a:rPr sz="2000"/>
-              <a:t>40 rambling trip reports · ~300 gear reviews · 200 trails · 25 park regulation docs · a visitor-inquiry inbox · ~500 trail-condition reports · mock weather/campsite/permit APIs</a:t>
+              <a:t>Ollama today, Azure OpenAI tomorrow, is a change in DI registration, not in the feature</a:t>
             </a:r>
           </a:p>
           <a:p>
             <a:pPr/>
             <a:r>
               <a:rPr sz="2000"/>
-              <a:t>Everything is synthetic. Do not plan a real trip from it.</a:t>
+              <a:t>Feature 03 does the swap live; feature 05 does it again for generation</a:t>
             </a:r>
           </a:p>
         </p:txBody>
@@ -5047,7 +5554,7 @@
           <a:lstStyle/>
           <a:p>
             <a:r>
-              <a:t>Row 0 of the Framework</a:t>
+              <a:t>Meet Trailhead Guides</a:t>
             </a:r>
           </a:p>
         </p:txBody>
@@ -5065,7 +5572,93 @@
         <p:spPr>
           <a:xfrm>
             <a:off x="612648" y="1600200"/>
-            <a:ext cx="10966399" cy="4800600"/>
+            <a:ext cx="10966399" cy="4892040"/>
+          </a:xfrm>
+        </p:spPr>
+        <p:txBody>
+          <a:bodyPr wrap="square"/>
+          <a:lstStyle/>
+          <a:p>
+            <a:pPr/>
+            <a:r>
+              <a:rPr sz="2000"/>
+              <a:t>A fictional national-park trip-planning app, one deliberately messy corpus, reused all day; each feature's data/ holds what its lab reads</a:t>
+            </a:r>
+          </a:p>
+          <a:p>
+            <a:pPr/>
+            <a:r>
+              <a:rPr sz="2000"/>
+              <a:t>40 rambling trip reports · ~300 gear reviews · 200 trails · 25 park regulation docs · a visitor-inquiry inbox · ~500 trail-condition reports · mock weather/campsite/permit APIs</a:t>
+            </a:r>
+          </a:p>
+          <a:p>
+            <a:pPr/>
+            <a:r>
+              <a:rPr sz="2000"/>
+              <a:t>Everything is synthetic. Do not plan a real trip from it.</a:t>
+            </a:r>
+          </a:p>
+        </p:txBody>
+      </p:sp>
+    </p:spTree>
+  </p:cSld>
+  <p:clrMapOvr>
+    <a:masterClrMapping/>
+  </p:clrMapOvr>
+</p:sld>
+</file>
+
+<file path=ppt/slides/slide16.xml><?xml version="1.0" encoding="utf-8"?>
+<p:sld xmlns:a="http://schemas.openxmlformats.org/drawingml/2006/main" xmlns:p="http://schemas.openxmlformats.org/presentationml/2006/main" xmlns:r="http://schemas.openxmlformats.org/officeDocument/2006/relationships">
+  <p:cSld>
+    <p:spTree>
+      <p:nvGrpSpPr>
+        <p:cNvPr id="1" name=""/>
+        <p:cNvGrpSpPr/>
+        <p:nvPr/>
+      </p:nvGrpSpPr>
+      <p:grpSpPr/>
+      <p:sp>
+        <p:nvSpPr>
+          <p:cNvPr id="2" name="Title 1"/>
+          <p:cNvSpPr>
+            <a:spLocks noGrp="1"/>
+          </p:cNvSpPr>
+          <p:nvPr>
+            <p:ph type="title"/>
+          </p:nvPr>
+        </p:nvSpPr>
+        <p:spPr>
+          <a:xfrm>
+            <a:off x="612648" y="365760"/>
+            <a:ext cx="10966399" cy="1097280"/>
+          </a:xfrm>
+        </p:spPr>
+        <p:txBody>
+          <a:bodyPr/>
+          <a:lstStyle/>
+          <a:p>
+            <a:r>
+              <a:t>Row 0 of the Framework</a:t>
+            </a:r>
+          </a:p>
+        </p:txBody>
+      </p:sp>
+      <p:sp>
+        <p:nvSpPr>
+          <p:cNvPr id="3" name="Content Placeholder 2"/>
+          <p:cNvSpPr>
+            <a:spLocks noGrp="1"/>
+          </p:cNvSpPr>
+          <p:nvPr>
+            <p:ph idx="1"/>
+          </p:nvPr>
+        </p:nvSpPr>
+        <p:spPr>
+          <a:xfrm>
+            <a:off x="612648" y="1600200"/>
+            <a:ext cx="10966399" cy="4892040"/>
           </a:xfrm>
         </p:spPr>
         <p:txBody>
@@ -5151,7 +5744,7 @@
         <p:spPr>
           <a:xfrm>
             <a:off x="612648" y="1600200"/>
-            <a:ext cx="10966399" cy="4800600"/>
+            <a:ext cx="10966399" cy="4892040"/>
           </a:xfrm>
         </p:spPr>
         <p:txBody>
@@ -5258,7 +5851,7 @@
         <p:spPr>
           <a:xfrm>
             <a:off x="612648" y="1600200"/>
-            <a:ext cx="10966399" cy="4800600"/>
+            <a:ext cx="10966399" cy="4892040"/>
           </a:xfrm>
         </p:spPr>
         <p:txBody>
@@ -5351,7 +5944,7 @@
         <p:spPr>
           <a:xfrm>
             <a:off x="612648" y="1600200"/>
-            <a:ext cx="10966399" cy="4800600"/>
+            <a:ext cx="10966399" cy="4892040"/>
           </a:xfrm>
         </p:spPr>
         <p:txBody>
@@ -5437,7 +6030,7 @@
         <p:spPr>
           <a:xfrm>
             <a:off x="612648" y="1600200"/>
-            <a:ext cx="10966399" cy="4800600"/>
+            <a:ext cx="10966399" cy="4892040"/>
           </a:xfrm>
         </p:spPr>
         <p:txBody>
@@ -5530,7 +6123,7 @@
         <p:spPr>
           <a:xfrm>
             <a:off x="612648" y="1600200"/>
-            <a:ext cx="10966399" cy="4800600"/>
+            <a:ext cx="10966399" cy="4892040"/>
           </a:xfrm>
         </p:spPr>
         <p:txBody>
@@ -5644,7 +6237,7 @@
         <p:spPr>
           <a:xfrm>
             <a:off x="612648" y="1600200"/>
-            <a:ext cx="10966399" cy="4800600"/>
+            <a:ext cx="10966399" cy="4892040"/>
           </a:xfrm>
         </p:spPr>
         <p:txBody>
@@ -5744,7 +6337,7 @@
         <p:spPr>
           <a:xfrm>
             <a:off x="612648" y="1600200"/>
-            <a:ext cx="10966399" cy="4800600"/>
+            <a:ext cx="10966399" cy="4892040"/>
           </a:xfrm>
         </p:spPr>
         <p:txBody>
@@ -5851,7 +6444,7 @@
         <p:spPr>
           <a:xfrm>
             <a:off x="612648" y="1600200"/>
-            <a:ext cx="10966399" cy="4800600"/>
+            <a:ext cx="10966399" cy="4892040"/>
           </a:xfrm>
         </p:spPr>
         <p:txBody>

</xml_diff>